<commit_message>
phase3: realize planner physical review core
</commit_message>
<xml_diff>
--- a/thesis-deck-system/artifacts/phase3/planner-composition-candidate-review.pptx
+++ b/thesis-deck-system/artifacts/phase3/planner-composition-candidate-review.pptx
@@ -15,6 +15,7 @@
     <p:sldId id="263" r:id="rId15"/>
     <p:sldId id="264" r:id="rId16"/>
     <p:sldId id="265" r:id="rId17"/>
+    <p:sldId id="266" r:id="rId18"/>
   </p:sldIdLst>
   <p:sldSz cx="12191999" cy="6858000" type="screen4x3"/>
   <p:notesSz cx="6858000" cy="9144000"/>
@@ -519,7 +520,31 @@
               <a:t>[/Sources]</a:t>
             </a:r>
           </a:p>
-          <a:p/>
+          <a:p>
+            <a:r>
+              <a:t>logical_slide_id=PPA-CASE-A-EXPERIMENT</a:t>
+            </a:r>
+          </a:p>
+          <a:p>
+            <a:r>
+              <a:t>candidate_id=PPC-A118F5613DDB64C3</a:t>
+            </a:r>
+          </a:p>
+          <a:p>
+            <a:r>
+              <a:t>body_family_id=BCF-HARDWARE-DESIGN-PROCEDURE</a:t>
+            </a:r>
+          </a:p>
+          <a:p>
+            <a:r>
+              <a:t>selected=True</a:t>
+            </a:r>
+          </a:p>
+          <a:p>
+            <a:r>
+              <a:t>synthetic_non_evidence=true</a:t>
+            </a:r>
+          </a:p>
         </p:txBody>
       </p:sp>
       <p:sp>
@@ -595,7 +620,131 @@
               <a:t>[/Sources]</a:t>
             </a:r>
           </a:p>
-          <a:p/>
+          <a:p>
+            <a:r>
+              <a:t>logical_slide_id=PPA-CASE-J-DIVERSITY</a:t>
+            </a:r>
+          </a:p>
+          <a:p>
+            <a:r>
+              <a:t>candidate_id=PPC-8B074929C8B57B90</a:t>
+            </a:r>
+          </a:p>
+          <a:p>
+            <a:r>
+              <a:t>body_family_id=BCF-THREE-COLUMN-PHYSICAL-COMPARISON</a:t>
+            </a:r>
+          </a:p>
+          <a:p>
+            <a:r>
+              <a:t>selected=True</a:t>
+            </a:r>
+          </a:p>
+          <a:p>
+            <a:r>
+              <a:t>synthetic_non_evidence=true</a:t>
+            </a:r>
+          </a:p>
+        </p:txBody>
+      </p:sp>
+      <p:sp>
+        <p:nvSpPr>
+          <p:cNvPr id="4" name="Slide Number Placeholder 3"/>
+          <p:cNvSpPr>
+            <a:spLocks noGrp="1"/>
+          </p:cNvSpPr>
+          <p:nvPr>
+            <p:ph type="sldNum" idx="5" sz="quarter"/>
+          </p:nvPr>
+        </p:nvSpPr>
+        <p:spPr/>
+      </p:sp>
+    </p:spTree>
+  </p:cSld>
+  <p:clrMapOvr>
+    <a:masterClrMapping/>
+  </p:clrMapOvr>
+</p:notes>
+</file>
+
+<file path=ppt/notesSlides/notesSlide11.xml><?xml version="1.0" encoding="utf-8"?>
+<p:notes xmlns:a="http://schemas.openxmlformats.org/drawingml/2006/main" xmlns:p="http://schemas.openxmlformats.org/presentationml/2006/main" xmlns:r="http://schemas.openxmlformats.org/officeDocument/2006/relationships">
+  <p:cSld>
+    <p:spTree>
+      <p:nvGrpSpPr>
+        <p:cNvPr id="1" name=""/>
+        <p:cNvGrpSpPr/>
+        <p:nvPr/>
+      </p:nvGrpSpPr>
+      <p:grpSpPr>
+        <a:xfrm>
+          <a:off x="0" y="0"/>
+          <a:ext cx="0" cy="0"/>
+          <a:chOff x="0" y="0"/>
+          <a:chExt cx="0" cy="0"/>
+        </a:xfrm>
+      </p:grpSpPr>
+      <p:sp>
+        <p:nvSpPr>
+          <p:cNvPr id="2" name="Slide Image Placeholder 1"/>
+          <p:cNvSpPr>
+            <a:spLocks noGrp="1"/>
+          </p:cNvSpPr>
+          <p:nvPr>
+            <p:ph type="sldImg" idx="2"/>
+          </p:nvPr>
+        </p:nvSpPr>
+        <p:spPr/>
+      </p:sp>
+      <p:sp>
+        <p:nvSpPr>
+          <p:cNvPr id="3" name="Notes Placeholder 2"/>
+          <p:cNvSpPr>
+            <a:spLocks noGrp="1"/>
+          </p:cNvSpPr>
+          <p:nvPr>
+            <p:ph type="body" idx="3" sz="quarter"/>
+          </p:nvPr>
+        </p:nvSpPr>
+        <p:spPr/>
+        <p:txBody>
+          <a:bodyPr/>
+          <a:lstStyle/>
+          <a:p>
+            <a:r>
+              <a:t>[Sources]</a:t>
+            </a:r>
+          </a:p>
+          <a:p>
+            <a:r>
+              <a:t>[/Sources]</a:t>
+            </a:r>
+          </a:p>
+          <a:p>
+            <a:r>
+              <a:t>logical_slide_id=PPA-CASE-J-DIVERSITY</a:t>
+            </a:r>
+          </a:p>
+          <a:p>
+            <a:r>
+              <a:t>candidate_id=PPC-EFFDE13A1C6DCF85</a:t>
+            </a:r>
+          </a:p>
+          <a:p>
+            <a:r>
+              <a:t>body_family_id=BCF-PHYSICAL-VALIDATION-MATRIX</a:t>
+            </a:r>
+          </a:p>
+          <a:p>
+            <a:r>
+              <a:t>selected=False</a:t>
+            </a:r>
+          </a:p>
+          <a:p>
+            <a:r>
+              <a:t>synthetic_non_evidence=true</a:t>
+            </a:r>
+          </a:p>
         </p:txBody>
       </p:sp>
       <p:sp>
@@ -671,7 +820,31 @@
               <a:t>[/Sources]</a:t>
             </a:r>
           </a:p>
-          <a:p/>
+          <a:p>
+            <a:r>
+              <a:t>logical_slide_id=PPA-CASE-B-PHYSICAL</a:t>
+            </a:r>
+          </a:p>
+          <a:p>
+            <a:r>
+              <a:t>candidate_id=PPC-096AA5FA0BA06EE1</a:t>
+            </a:r>
+          </a:p>
+          <a:p>
+            <a:r>
+              <a:t>body_family_id=BCF-PHYSICAL-VALIDATION-MATRIX</a:t>
+            </a:r>
+          </a:p>
+          <a:p>
+            <a:r>
+              <a:t>selected=True</a:t>
+            </a:r>
+          </a:p>
+          <a:p>
+            <a:r>
+              <a:t>synthetic_non_evidence=true</a:t>
+            </a:r>
+          </a:p>
         </p:txBody>
       </p:sp>
       <p:sp>
@@ -747,7 +920,31 @@
               <a:t>[/Sources]</a:t>
             </a:r>
           </a:p>
-          <a:p/>
+          <a:p>
+            <a:r>
+              <a:t>logical_slide_id=PPA-CASE-C-RESULT</a:t>
+            </a:r>
+          </a:p>
+          <a:p>
+            <a:r>
+              <a:t>candidate_id=PPC-6DC7B591568B4649</a:t>
+            </a:r>
+          </a:p>
+          <a:p>
+            <a:r>
+              <a:t>body_family_id=BCF-REAL-RESULT-VALIDATION</a:t>
+            </a:r>
+          </a:p>
+          <a:p>
+            <a:r>
+              <a:t>selected=True</a:t>
+            </a:r>
+          </a:p>
+          <a:p>
+            <a:r>
+              <a:t>synthetic_non_evidence=true</a:t>
+            </a:r>
+          </a:p>
         </p:txBody>
       </p:sp>
       <p:sp>
@@ -823,7 +1020,31 @@
               <a:t>[/Sources]</a:t>
             </a:r>
           </a:p>
-          <a:p/>
+          <a:p>
+            <a:r>
+              <a:t>logical_slide_id=PPA-CASE-D-MULTIMODAL</a:t>
+            </a:r>
+          </a:p>
+          <a:p>
+            <a:r>
+              <a:t>candidate_id=PPC-B2E8AD28884FEC68</a:t>
+            </a:r>
+          </a:p>
+          <a:p>
+            <a:r>
+              <a:t>body_family_id=BCF-PHYSICAL-VALIDATION-MATRIX</a:t>
+            </a:r>
+          </a:p>
+          <a:p>
+            <a:r>
+              <a:t>selected=True</a:t>
+            </a:r>
+          </a:p>
+          <a:p>
+            <a:r>
+              <a:t>synthetic_non_evidence=true</a:t>
+            </a:r>
+          </a:p>
         </p:txBody>
       </p:sp>
       <p:sp>
@@ -899,7 +1120,31 @@
               <a:t>[/Sources]</a:t>
             </a:r>
           </a:p>
-          <a:p/>
+          <a:p>
+            <a:r>
+              <a:t>logical_slide_id=PPA-CASE-E-LITERATURE</a:t>
+            </a:r>
+          </a:p>
+          <a:p>
+            <a:r>
+              <a:t>candidate_id=PPC-2067AD3AC8E29B97</a:t>
+            </a:r>
+          </a:p>
+          <a:p>
+            <a:r>
+              <a:t>body_family_id=BCF-LITERATURE-VISUAL-MATRIX</a:t>
+            </a:r>
+          </a:p>
+          <a:p>
+            <a:r>
+              <a:t>selected=True</a:t>
+            </a:r>
+          </a:p>
+          <a:p>
+            <a:r>
+              <a:t>synthetic_non_evidence=true</a:t>
+            </a:r>
+          </a:p>
         </p:txBody>
       </p:sp>
       <p:sp>
@@ -975,7 +1220,31 @@
               <a:t>[/Sources]</a:t>
             </a:r>
           </a:p>
-          <a:p/>
+          <a:p>
+            <a:r>
+              <a:t>logical_slide_id=PPA-CASE-F-COMPARISON</a:t>
+            </a:r>
+          </a:p>
+          <a:p>
+            <a:r>
+              <a:t>candidate_id=PPC-1BB2BEBF7E6618D7</a:t>
+            </a:r>
+          </a:p>
+          <a:p>
+            <a:r>
+              <a:t>body_family_id=BCF-TECHNOLOGY-COMPARISON</a:t>
+            </a:r>
+          </a:p>
+          <a:p>
+            <a:r>
+              <a:t>selected=True</a:t>
+            </a:r>
+          </a:p>
+          <a:p>
+            <a:r>
+              <a:t>synthetic_non_evidence=true</a:t>
+            </a:r>
+          </a:p>
         </p:txBody>
       </p:sp>
       <p:sp>
@@ -1051,7 +1320,31 @@
               <a:t>[/Sources]</a:t>
             </a:r>
           </a:p>
-          <a:p/>
+          <a:p>
+            <a:r>
+              <a:t>logical_slide_id=PPA-CASE-G-PRINCIPLE</a:t>
+            </a:r>
+          </a:p>
+          <a:p>
+            <a:r>
+              <a:t>candidate_id=PPC-E866D0D74E77404B</a:t>
+            </a:r>
+          </a:p>
+          <a:p>
+            <a:r>
+              <a:t>body_family_id=BCF-PRINCIPLE-EQUIPMENT-SPLIT</a:t>
+            </a:r>
+          </a:p>
+          <a:p>
+            <a:r>
+              <a:t>selected=True</a:t>
+            </a:r>
+          </a:p>
+          <a:p>
+            <a:r>
+              <a:t>synthetic_non_evidence=true</a:t>
+            </a:r>
+          </a:p>
         </p:txBody>
       </p:sp>
       <p:sp>
@@ -1127,7 +1420,31 @@
               <a:t>[/Sources]</a:t>
             </a:r>
           </a:p>
-          <a:p/>
+          <a:p>
+            <a:r>
+              <a:t>logical_slide_id=PPA-CASE-H-HISTORICAL</a:t>
+            </a:r>
+          </a:p>
+          <a:p>
+            <a:r>
+              <a:t>candidate_id=PPC-468E2014216AC345</a:t>
+            </a:r>
+          </a:p>
+          <a:p>
+            <a:r>
+              <a:t>body_family_id=BCF-REAL-RESULT-VALIDATION</a:t>
+            </a:r>
+          </a:p>
+          <a:p>
+            <a:r>
+              <a:t>selected=True</a:t>
+            </a:r>
+          </a:p>
+          <a:p>
+            <a:r>
+              <a:t>synthetic_non_evidence=true</a:t>
+            </a:r>
+          </a:p>
         </p:txBody>
       </p:sp>
       <p:sp>
@@ -1203,7 +1520,31 @@
               <a:t>[/Sources]</a:t>
             </a:r>
           </a:p>
-          <a:p/>
+          <a:p>
+            <a:r>
+              <a:t>logical_slide_id=PPA-CASE-I-CONTINUATION</a:t>
+            </a:r>
+          </a:p>
+          <a:p>
+            <a:r>
+              <a:t>candidate_id=PPC-F1CFC7CC4822B5C0</a:t>
+            </a:r>
+          </a:p>
+          <a:p>
+            <a:r>
+              <a:t>body_family_id=BCF-HARDWARE-DESIGN-PROCEDURE</a:t>
+            </a:r>
+          </a:p>
+          <a:p>
+            <a:r>
+              <a:t>selected=True</a:t>
+            </a:r>
+          </a:p>
+          <a:p>
+            <a:r>
+              <a:t>synthetic_non_evidence=true</a:t>
+            </a:r>
+          </a:p>
         </p:txBody>
       </p:sp>
       <p:sp>
@@ -4209,7 +4550,7 @@
       <p:grpSpPr/>
       <p:sp>
         <p:nvSpPr>
-          <p:cNvPr id="2" name="tds-title:PPA-CASE-A-EXPERIMENT"/>
+          <p:cNvPr id="2" name="tds-title:PPA-CASE-A-EXPERIMENT::PPC-A118F5613DDB64C3"/>
           <p:cNvSpPr>
             <a:spLocks noGrp="1"/>
           </p:cNvSpPr>
@@ -4229,7 +4570,7 @@
           <a:p>
             <a:r>
               <a:rPr sz="2200"/>
-              <a:t>Planner review CASE-A-EXPERIMENT</a:t>
+              <a:t>Planner review CASE-A-EXPERIMENT | BCF-HARDWARE-DESIGN-PROCEDURE</a:t>
             </a:r>
           </a:p>
         </p:txBody>
@@ -4253,14 +4594,14 @@
       </p:sp>
       <p:sp>
         <p:nvSpPr>
-          <p:cNvPr id="4" name="tds-composition-text:PPA-CASE-A-EXPERIMENT"/>
+          <p:cNvPr id="4" name="PPA::PPA-CASE-A-EXPERIMENT::PPC-A118F5613DDB64C3::hardware::primary_visual::CAD"/>
           <p:cNvSpPr txBox="1"/>
           <p:nvPr/>
         </p:nvSpPr>
         <p:spPr>
           <a:xfrm>
-            <a:off x="640080" y="1280160"/>
-            <a:ext cx="3566160" cy="4297680"/>
+            <a:off x="1073505" y="1376172"/>
+            <a:ext cx="6067958" cy="3264408"/>
           </a:xfrm>
           <a:prstGeom prst="rect">
             <a:avLst/>
@@ -4274,22 +4615,84 @@
           <a:lstStyle/>
           <a:p>
             <a:r>
-              <a:rPr sz="1800"/>
-              <a:t>BCF-FEASIBILITY-EVIDENCE-MATRIX</a:t>
-            </a:r>
-          </a:p>
-          <a:p/>
-          <a:p>
-            <a:r>
-              <a:rPr sz="1800"/>
-              <a:t>experiment_visual / evidence_matrix / caption_strip</a:t>
-            </a:r>
-          </a:p>
-          <a:p/>
-          <a:p>
-            <a:r>
-              <a:rPr sz="1800"/>
-              <a:t>automatic</a:t>
+              <a:rPr sz="1200"/>
+              <a:t>SYNTHETIC_NON_EVIDENCE</a:t>
+            </a:r>
+          </a:p>
+          <a:p>
+            <a:r>
+              <a:rPr sz="1200"/>
+              <a:t>primary_visual</a:t>
+            </a:r>
+          </a:p>
+        </p:txBody>
+      </p:sp>
+      <p:sp>
+        <p:nvSpPr>
+          <p:cNvPr id="5" name="PPA::PPA-CASE-A-EXPERIMENT::PPC-A118F5613DDB64C3::procedure::procedure::CONTROLS"/>
+          <p:cNvSpPr txBox="1"/>
+          <p:nvPr/>
+        </p:nvSpPr>
+        <p:spPr>
+          <a:xfrm>
+            <a:off x="7683246" y="1376172"/>
+            <a:ext cx="3359048" cy="2238451"/>
+          </a:xfrm>
+          <a:prstGeom prst="rect">
+            <a:avLst/>
+          </a:prstGeom>
+          <a:noFill/>
+        </p:spPr>
+        <p:txBody>
+          <a:bodyPr wrap="none">
+            <a:spAutoFit/>
+          </a:bodyPr>
+          <a:lstStyle/>
+          <a:p>
+            <a:r>
+              <a:rPr sz="1200"/>
+              <a:t>SYNTHETIC_NON_EVIDENCE</a:t>
+            </a:r>
+          </a:p>
+          <a:p>
+            <a:r>
+              <a:rPr sz="1200"/>
+              <a:t>procedure</a:t>
+            </a:r>
+          </a:p>
+        </p:txBody>
+      </p:sp>
+      <p:sp>
+        <p:nvSpPr>
+          <p:cNvPr id="6" name="PPA::PPA-CASE-A-EXPERIMENT::PPC-A118F5613DDB64C3::go::go_criterion::GO"/>
+          <p:cNvSpPr txBox="1"/>
+          <p:nvPr/>
+        </p:nvSpPr>
+        <p:spPr>
+          <a:xfrm>
+            <a:off x="7683246" y="3941063"/>
+            <a:ext cx="3359048" cy="746150"/>
+          </a:xfrm>
+          <a:prstGeom prst="rect">
+            <a:avLst/>
+          </a:prstGeom>
+          <a:noFill/>
+        </p:spPr>
+        <p:txBody>
+          <a:bodyPr wrap="none">
+            <a:spAutoFit/>
+          </a:bodyPr>
+          <a:lstStyle/>
+          <a:p>
+            <a:r>
+              <a:rPr sz="1200"/>
+              <a:t>SYNTHETIC_NON_EVIDENCE</a:t>
+            </a:r>
+          </a:p>
+          <a:p>
+            <a:r>
+              <a:rPr sz="1200"/>
+              <a:t>go_criterion</a:t>
             </a:r>
           </a:p>
         </p:txBody>
@@ -4314,7 +4717,7 @@
       <p:grpSpPr/>
       <p:sp>
         <p:nvSpPr>
-          <p:cNvPr id="2" name="tds-title:PPA-CASE-J-DIVERSITY"/>
+          <p:cNvPr id="2" name="tds-title:PPA-CASE-J-DIVERSITY::PPC-8B074929C8B57B90"/>
           <p:cNvSpPr>
             <a:spLocks noGrp="1"/>
           </p:cNvSpPr>
@@ -4334,7 +4737,7 @@
           <a:p>
             <a:r>
               <a:rPr sz="2200"/>
-              <a:t>Planner review CASE-J-DIVERSITY</a:t>
+              <a:t>Planner review CASE-J-DIVERSITY | BCF-THREE-COLUMN-PHYSICAL-COMPARISON</a:t>
             </a:r>
           </a:p>
         </p:txBody>
@@ -4358,14 +4761,14 @@
       </p:sp>
       <p:sp>
         <p:nvSpPr>
-          <p:cNvPr id="4" name="tds-composition-text:PPA-CASE-J-DIVERSITY"/>
+          <p:cNvPr id="4" name="PPA::PPA-CASE-J-DIVERSITY::PPC-8B074929C8B57B90::column_a::primary_visual::P1"/>
           <p:cNvSpPr txBox="1"/>
           <p:nvPr/>
         </p:nvSpPr>
         <p:spPr>
           <a:xfrm>
-            <a:off x="640080" y="1280160"/>
-            <a:ext cx="3566160" cy="4297680"/>
+            <a:off x="1073505" y="1422806"/>
+            <a:ext cx="2925622" cy="2611526"/>
           </a:xfrm>
           <a:prstGeom prst="rect">
             <a:avLst/>
@@ -4379,22 +4782,461 @@
           <a:lstStyle/>
           <a:p>
             <a:r>
-              <a:rPr sz="1800"/>
-              <a:t>BCF-PHYSICAL-VALIDATION-MATRIX</a:t>
-            </a:r>
-          </a:p>
+              <a:rPr sz="1200"/>
+              <a:t>SYNTHETIC_NON_EVIDENCE</a:t>
+            </a:r>
+          </a:p>
+          <a:p>
+            <a:r>
+              <a:rPr sz="1200"/>
+              <a:t>primary_visual</a:t>
+            </a:r>
+          </a:p>
+        </p:txBody>
+      </p:sp>
+      <p:sp>
+        <p:nvSpPr>
+          <p:cNvPr id="5" name="PPA::PPA-CASE-J-DIVERSITY::PPC-8B074929C8B57B90::column_b::secondary_visual::P2"/>
+          <p:cNvSpPr txBox="1"/>
+          <p:nvPr/>
+        </p:nvSpPr>
+        <p:spPr>
+          <a:xfrm>
+            <a:off x="4595088" y="1422806"/>
+            <a:ext cx="2925622" cy="2611526"/>
+          </a:xfrm>
+          <a:prstGeom prst="rect">
+            <a:avLst/>
+          </a:prstGeom>
+          <a:noFill/>
+        </p:spPr>
+        <p:txBody>
+          <a:bodyPr wrap="none">
+            <a:spAutoFit/>
+          </a:bodyPr>
+          <a:lstStyle/>
+          <a:p>
+            <a:r>
+              <a:rPr sz="1200"/>
+              <a:t>SYNTHETIC_NON_EVIDENCE</a:t>
+            </a:r>
+          </a:p>
+          <a:p>
+            <a:r>
+              <a:rPr sz="1200"/>
+              <a:t>secondary_visual</a:t>
+            </a:r>
+          </a:p>
+        </p:txBody>
+      </p:sp>
+      <p:sp>
+        <p:nvSpPr>
+          <p:cNvPr id="6" name="PPA::PPA-CASE-J-DIVERSITY::PPC-8B074929C8B57B90::column_c::secondary_visual::P3"/>
+          <p:cNvSpPr txBox="1"/>
+          <p:nvPr/>
+        </p:nvSpPr>
+        <p:spPr>
+          <a:xfrm>
+            <a:off x="8116671" y="1422806"/>
+            <a:ext cx="2925622" cy="2611526"/>
+          </a:xfrm>
+          <a:prstGeom prst="rect">
+            <a:avLst/>
+          </a:prstGeom>
+          <a:noFill/>
+        </p:spPr>
+        <p:txBody>
+          <a:bodyPr wrap="none">
+            <a:spAutoFit/>
+          </a:bodyPr>
+          <a:lstStyle/>
+          <a:p>
+            <a:r>
+              <a:rPr sz="1200"/>
+              <a:t>SYNTHETIC_NON_EVIDENCE</a:t>
+            </a:r>
+          </a:p>
+          <a:p>
+            <a:r>
+              <a:rPr sz="1200"/>
+              <a:t>secondary_visual</a:t>
+            </a:r>
+          </a:p>
+        </p:txBody>
+      </p:sp>
+      <p:sp>
+        <p:nvSpPr>
+          <p:cNvPr id="7" name="PPA::PPA-CASE-J-DIVERSITY::PPC-8B074929C8B57B90::criteria::criteria_strip::REGION-CRITERIA"/>
+          <p:cNvSpPr txBox="1"/>
+          <p:nvPr/>
+        </p:nvSpPr>
+        <p:spPr>
+          <a:xfrm>
+            <a:off x="1073505" y="4407408"/>
+            <a:ext cx="6501384" cy="559612"/>
+          </a:xfrm>
+          <a:prstGeom prst="rect">
+            <a:avLst/>
+          </a:prstGeom>
+          <a:noFill/>
+        </p:spPr>
+        <p:txBody>
+          <a:bodyPr wrap="none">
+            <a:spAutoFit/>
+          </a:bodyPr>
+          <a:lstStyle/>
+          <a:p>
+            <a:r>
+              <a:rPr sz="1200"/>
+              <a:t>SYNTHETIC_NON_EVIDENCE</a:t>
+            </a:r>
+          </a:p>
+          <a:p>
+            <a:r>
+              <a:rPr sz="1200"/>
+              <a:t>criteria_strip</a:t>
+            </a:r>
+          </a:p>
+        </p:txBody>
+      </p:sp>
+      <p:sp>
+        <p:nvSpPr>
+          <p:cNvPr id="8" name="PPA::PPA-CASE-J-DIVERSITY::PPC-8B074929C8B57B90::decision::decision_callout::REGION-DECISION"/>
+          <p:cNvSpPr txBox="1"/>
+          <p:nvPr/>
+        </p:nvSpPr>
+        <p:spPr>
+          <a:xfrm>
+            <a:off x="8225027" y="4407408"/>
+            <a:ext cx="2817266" cy="559612"/>
+          </a:xfrm>
+          <a:prstGeom prst="rect">
+            <a:avLst/>
+          </a:prstGeom>
+          <a:noFill/>
+        </p:spPr>
+        <p:txBody>
+          <a:bodyPr wrap="none">
+            <a:spAutoFit/>
+          </a:bodyPr>
+          <a:lstStyle/>
+          <a:p>
+            <a:r>
+              <a:rPr sz="1200"/>
+              <a:t>SYNTHETIC_NON_EVIDENCE</a:t>
+            </a:r>
+          </a:p>
+          <a:p>
+            <a:r>
+              <a:rPr sz="1200"/>
+              <a:t>decision_callout</a:t>
+            </a:r>
+          </a:p>
+        </p:txBody>
+      </p:sp>
+    </p:spTree>
+  </p:cSld>
+  <p:clrMapOvr>
+    <a:masterClrMapping/>
+  </p:clrMapOvr>
+</p:sld>
+</file>
+
+<file path=ppt/slides/slide11.xml><?xml version="1.0" encoding="utf-8"?>
+<p:sld xmlns:a="http://schemas.openxmlformats.org/drawingml/2006/main" xmlns:p="http://schemas.openxmlformats.org/presentationml/2006/main" xmlns:r="http://schemas.openxmlformats.org/officeDocument/2006/relationships">
+  <p:cSld>
+    <p:spTree>
+      <p:nvGrpSpPr>
+        <p:cNvPr id="1" name=""/>
+        <p:cNvGrpSpPr/>
+        <p:nvPr/>
+      </p:nvGrpSpPr>
+      <p:grpSpPr/>
+      <p:sp>
+        <p:nvSpPr>
+          <p:cNvPr id="2" name="tds-title:PPA-CASE-J-DIVERSITY::PPC-EFFDE13A1C6DCF85"/>
+          <p:cNvSpPr>
+            <a:spLocks noGrp="1"/>
+          </p:cNvSpPr>
+          <p:nvPr>
+            <p:ph type="title"/>
+          </p:nvPr>
+        </p:nvSpPr>
+        <p:spPr>
+          <a:xfrm>
+            <a:off x="502920" y="201168"/>
+            <a:ext cx="11109960" cy="685800"/>
+          </a:xfrm>
+        </p:spPr>
+        <p:txBody>
+          <a:bodyPr lIns="0" rIns="0" tIns="0" bIns="0"/>
+          <a:lstStyle/>
+          <a:p>
+            <a:r>
+              <a:rPr sz="2200"/>
+              <a:t>Planner review CASE-J-DIVERSITY | BCF-PHYSICAL-VALIDATION-MATRIX</a:t>
+            </a:r>
+          </a:p>
+        </p:txBody>
+      </p:sp>
+      <p:sp>
+        <p:nvSpPr>
+          <p:cNvPr id="3" name="Content Placeholder 2"/>
+          <p:cNvSpPr>
+            <a:spLocks noGrp="1"/>
+          </p:cNvSpPr>
+          <p:nvPr>
+            <p:ph idx="1"/>
+          </p:nvPr>
+        </p:nvSpPr>
+        <p:spPr/>
+        <p:txBody>
+          <a:bodyPr/>
+          <a:lstStyle/>
           <a:p/>
-          <a:p>
-            <a:r>
-              <a:rPr sz="1800"/>
-              <a:t>physical_visual_grid / validation_plot / caption_matrix</a:t>
-            </a:r>
-          </a:p>
-          <a:p/>
-          <a:p>
-            <a:r>
-              <a:rPr sz="1800"/>
-              <a:t>automatic</a:t>
+        </p:txBody>
+      </p:sp>
+      <p:sp>
+        <p:nvSpPr>
+          <p:cNvPr id="4" name="PPA::PPA-CASE-J-DIVERSITY::PPC-EFFDE13A1C6DCF85::photo_a::primary_visual::P1"/>
+          <p:cNvSpPr txBox="1"/>
+          <p:nvPr/>
+        </p:nvSpPr>
+        <p:spPr>
+          <a:xfrm>
+            <a:off x="1073505" y="1376172"/>
+            <a:ext cx="3033979" cy="1538935"/>
+          </a:xfrm>
+          <a:prstGeom prst="rect">
+            <a:avLst/>
+          </a:prstGeom>
+          <a:noFill/>
+        </p:spPr>
+        <p:txBody>
+          <a:bodyPr wrap="none">
+            <a:spAutoFit/>
+          </a:bodyPr>
+          <a:lstStyle/>
+          <a:p>
+            <a:r>
+              <a:rPr sz="1200"/>
+              <a:t>SYNTHETIC_NON_EVIDENCE</a:t>
+            </a:r>
+          </a:p>
+          <a:p>
+            <a:r>
+              <a:rPr sz="1200"/>
+              <a:t>primary_visual</a:t>
+            </a:r>
+          </a:p>
+        </p:txBody>
+      </p:sp>
+      <p:sp>
+        <p:nvSpPr>
+          <p:cNvPr id="5" name="PPA::PPA-CASE-J-DIVERSITY::PPC-EFFDE13A1C6DCF85::photo_b::secondary_visual::P3"/>
+          <p:cNvSpPr txBox="1"/>
+          <p:nvPr/>
+        </p:nvSpPr>
+        <p:spPr>
+          <a:xfrm>
+            <a:off x="4432554" y="1376172"/>
+            <a:ext cx="3033979" cy="1538935"/>
+          </a:xfrm>
+          <a:prstGeom prst="rect">
+            <a:avLst/>
+          </a:prstGeom>
+          <a:noFill/>
+        </p:spPr>
+        <p:txBody>
+          <a:bodyPr wrap="none">
+            <a:spAutoFit/>
+          </a:bodyPr>
+          <a:lstStyle/>
+          <a:p>
+            <a:r>
+              <a:rPr sz="1200"/>
+              <a:t>SYNTHETIC_NON_EVIDENCE</a:t>
+            </a:r>
+          </a:p>
+          <a:p>
+            <a:r>
+              <a:rPr sz="1200"/>
+              <a:t>secondary_visual</a:t>
+            </a:r>
+          </a:p>
+        </p:txBody>
+      </p:sp>
+      <p:sp>
+        <p:nvSpPr>
+          <p:cNvPr id="6" name="PPA::PPA-CASE-J-DIVERSITY::PPC-EFFDE13A1C6DCF85::plot::validation_plot::REGION-PLOT"/>
+          <p:cNvSpPr txBox="1"/>
+          <p:nvPr/>
+        </p:nvSpPr>
+        <p:spPr>
+          <a:xfrm>
+            <a:off x="7791602" y="1376172"/>
+            <a:ext cx="3250692" cy="2238451"/>
+          </a:xfrm>
+          <a:prstGeom prst="rect">
+            <a:avLst/>
+          </a:prstGeom>
+          <a:noFill/>
+        </p:spPr>
+        <p:txBody>
+          <a:bodyPr wrap="none">
+            <a:spAutoFit/>
+          </a:bodyPr>
+          <a:lstStyle/>
+          <a:p>
+            <a:r>
+              <a:rPr sz="1200"/>
+              <a:t>SYNTHETIC_NON_EVIDENCE</a:t>
+            </a:r>
+          </a:p>
+          <a:p>
+            <a:r>
+              <a:rPr sz="1200"/>
+              <a:t>validation_plot</a:t>
+            </a:r>
+          </a:p>
+        </p:txBody>
+      </p:sp>
+      <p:sp>
+        <p:nvSpPr>
+          <p:cNvPr id="7" name="PPA::PPA-CASE-J-DIVERSITY::PPC-EFFDE13A1C6DCF85::caption_a::caption::REGION-CAPTION_A"/>
+          <p:cNvSpPr txBox="1"/>
+          <p:nvPr/>
+        </p:nvSpPr>
+        <p:spPr>
+          <a:xfrm>
+            <a:off x="1073505" y="3101644"/>
+            <a:ext cx="3033979" cy="466344"/>
+          </a:xfrm>
+          <a:prstGeom prst="rect">
+            <a:avLst/>
+          </a:prstGeom>
+          <a:noFill/>
+        </p:spPr>
+        <p:txBody>
+          <a:bodyPr wrap="none">
+            <a:spAutoFit/>
+          </a:bodyPr>
+          <a:lstStyle/>
+          <a:p>
+            <a:r>
+              <a:rPr sz="1200"/>
+              <a:t>SYNTHETIC_NON_EVIDENCE</a:t>
+            </a:r>
+          </a:p>
+          <a:p>
+            <a:r>
+              <a:rPr sz="1200"/>
+              <a:t>caption</a:t>
+            </a:r>
+          </a:p>
+        </p:txBody>
+      </p:sp>
+      <p:sp>
+        <p:nvSpPr>
+          <p:cNvPr id="8" name="PPA::PPA-CASE-J-DIVERSITY::PPC-EFFDE13A1C6DCF85::caption_b::caption::REGION-CAPTION_B"/>
+          <p:cNvSpPr txBox="1"/>
+          <p:nvPr/>
+        </p:nvSpPr>
+        <p:spPr>
+          <a:xfrm>
+            <a:off x="4432554" y="3101644"/>
+            <a:ext cx="3033979" cy="466344"/>
+          </a:xfrm>
+          <a:prstGeom prst="rect">
+            <a:avLst/>
+          </a:prstGeom>
+          <a:noFill/>
+        </p:spPr>
+        <p:txBody>
+          <a:bodyPr wrap="none">
+            <a:spAutoFit/>
+          </a:bodyPr>
+          <a:lstStyle/>
+          <a:p>
+            <a:r>
+              <a:rPr sz="1200"/>
+              <a:t>SYNTHETIC_NON_EVIDENCE</a:t>
+            </a:r>
+          </a:p>
+          <a:p>
+            <a:r>
+              <a:rPr sz="1200"/>
+              <a:t>caption</a:t>
+            </a:r>
+          </a:p>
+        </p:txBody>
+      </p:sp>
+      <p:sp>
+        <p:nvSpPr>
+          <p:cNvPr id="9" name="PPA::PPA-CASE-J-DIVERSITY::PPC-EFFDE13A1C6DCF85::measurement_c::secondary_visual::P2"/>
+          <p:cNvSpPr txBox="1"/>
+          <p:nvPr/>
+        </p:nvSpPr>
+        <p:spPr>
+          <a:xfrm>
+            <a:off x="7791602" y="3847795"/>
+            <a:ext cx="3250692" cy="932688"/>
+          </a:xfrm>
+          <a:prstGeom prst="rect">
+            <a:avLst/>
+          </a:prstGeom>
+          <a:noFill/>
+        </p:spPr>
+        <p:txBody>
+          <a:bodyPr wrap="none">
+            <a:spAutoFit/>
+          </a:bodyPr>
+          <a:lstStyle/>
+          <a:p>
+            <a:r>
+              <a:rPr sz="1200"/>
+              <a:t>SYNTHETIC_NON_EVIDENCE</a:t>
+            </a:r>
+          </a:p>
+          <a:p>
+            <a:r>
+              <a:rPr sz="1200"/>
+              <a:t>secondary_visual</a:t>
+            </a:r>
+          </a:p>
+        </p:txBody>
+      </p:sp>
+      <p:sp>
+        <p:nvSpPr>
+          <p:cNvPr id="10" name="PPA::PPA-CASE-J-DIVERSITY::PPC-EFFDE13A1C6DCF85::context::compact_context::REGION-CONTEXT"/>
+          <p:cNvSpPr txBox="1"/>
+          <p:nvPr/>
+        </p:nvSpPr>
+        <p:spPr>
+          <a:xfrm>
+            <a:off x="1073505" y="4034332"/>
+            <a:ext cx="6393027" cy="792784"/>
+          </a:xfrm>
+          <a:prstGeom prst="rect">
+            <a:avLst/>
+          </a:prstGeom>
+          <a:noFill/>
+        </p:spPr>
+        <p:txBody>
+          <a:bodyPr wrap="none">
+            <a:spAutoFit/>
+          </a:bodyPr>
+          <a:lstStyle/>
+          <a:p>
+            <a:r>
+              <a:rPr sz="1200"/>
+              <a:t>SYNTHETIC_NON_EVIDENCE</a:t>
+            </a:r>
+          </a:p>
+          <a:p>
+            <a:r>
+              <a:rPr sz="1200"/>
+              <a:t>compact_context</a:t>
             </a:r>
           </a:p>
         </p:txBody>
@@ -4419,7 +5261,7 @@
       <p:grpSpPr/>
       <p:sp>
         <p:nvSpPr>
-          <p:cNvPr id="2" name="tds-title:PPA-CASE-B-PHYSICAL"/>
+          <p:cNvPr id="2" name="tds-title:PPA-CASE-B-PHYSICAL::PPC-096AA5FA0BA06EE1"/>
           <p:cNvSpPr>
             <a:spLocks noGrp="1"/>
           </p:cNvSpPr>
@@ -4439,7 +5281,7 @@
           <a:p>
             <a:r>
               <a:rPr sz="2200"/>
-              <a:t>Planner review CASE-B-PHYSICAL</a:t>
+              <a:t>Planner review CASE-B-PHYSICAL | BCF-PHYSICAL-VALIDATION-MATRIX</a:t>
             </a:r>
           </a:p>
         </p:txBody>
@@ -4463,14 +5305,14 @@
       </p:sp>
       <p:sp>
         <p:nvSpPr>
-          <p:cNvPr id="4" name="tds-composition-text:PPA-CASE-B-PHYSICAL"/>
+          <p:cNvPr id="4" name="PPA::PPA-CASE-B-PHYSICAL::PPC-096AA5FA0BA06EE1::photo_a::primary_visual::PHOTO-1"/>
           <p:cNvSpPr txBox="1"/>
           <p:nvPr/>
         </p:nvSpPr>
         <p:spPr>
           <a:xfrm>
-            <a:off x="640080" y="1280160"/>
-            <a:ext cx="3566160" cy="4297680"/>
+            <a:off x="1073505" y="1376172"/>
+            <a:ext cx="3033979" cy="1538935"/>
           </a:xfrm>
           <a:prstGeom prst="rect">
             <a:avLst/>
@@ -4484,22 +5326,224 @@
           <a:lstStyle/>
           <a:p>
             <a:r>
-              <a:rPr sz="1800"/>
-              <a:t>BCF-PHYSICAL-VALIDATION-MATRIX</a:t>
-            </a:r>
-          </a:p>
-          <a:p/>
-          <a:p>
-            <a:r>
-              <a:rPr sz="1800"/>
-              <a:t>physical_visual_grid / validation_plot / caption_matrix</a:t>
-            </a:r>
-          </a:p>
-          <a:p/>
-          <a:p>
-            <a:r>
-              <a:rPr sz="1800"/>
-              <a:t>automatic</a:t>
+              <a:rPr sz="1200"/>
+              <a:t>SYNTHETIC_NON_EVIDENCE</a:t>
+            </a:r>
+          </a:p>
+          <a:p>
+            <a:r>
+              <a:rPr sz="1200"/>
+              <a:t>primary_visual</a:t>
+            </a:r>
+          </a:p>
+        </p:txBody>
+      </p:sp>
+      <p:sp>
+        <p:nvSpPr>
+          <p:cNvPr id="5" name="PPA::PPA-CASE-B-PHYSICAL::PPC-096AA5FA0BA06EE1::photo_b::secondary_visual::PLOT-1"/>
+          <p:cNvSpPr txBox="1"/>
+          <p:nvPr/>
+        </p:nvSpPr>
+        <p:spPr>
+          <a:xfrm>
+            <a:off x="4432554" y="1376172"/>
+            <a:ext cx="3033979" cy="1538935"/>
+          </a:xfrm>
+          <a:prstGeom prst="rect">
+            <a:avLst/>
+          </a:prstGeom>
+          <a:noFill/>
+        </p:spPr>
+        <p:txBody>
+          <a:bodyPr wrap="none">
+            <a:spAutoFit/>
+          </a:bodyPr>
+          <a:lstStyle/>
+          <a:p>
+            <a:r>
+              <a:rPr sz="1200"/>
+              <a:t>SYNTHETIC_NON_EVIDENCE</a:t>
+            </a:r>
+          </a:p>
+          <a:p>
+            <a:r>
+              <a:rPr sz="1200"/>
+              <a:t>secondary_visual</a:t>
+            </a:r>
+          </a:p>
+        </p:txBody>
+      </p:sp>
+      <p:sp>
+        <p:nvSpPr>
+          <p:cNvPr id="6" name="PPA::PPA-CASE-B-PHYSICAL::PPC-096AA5FA0BA06EE1::plot::validation_plot::PLOT-2"/>
+          <p:cNvSpPr txBox="1"/>
+          <p:nvPr/>
+        </p:nvSpPr>
+        <p:spPr>
+          <a:xfrm>
+            <a:off x="7791602" y="1376172"/>
+            <a:ext cx="3250692" cy="2238451"/>
+          </a:xfrm>
+          <a:prstGeom prst="rect">
+            <a:avLst/>
+          </a:prstGeom>
+          <a:noFill/>
+        </p:spPr>
+        <p:txBody>
+          <a:bodyPr wrap="none">
+            <a:spAutoFit/>
+          </a:bodyPr>
+          <a:lstStyle/>
+          <a:p>
+            <a:r>
+              <a:rPr sz="1200"/>
+              <a:t>SYNTHETIC_NON_EVIDENCE</a:t>
+            </a:r>
+          </a:p>
+          <a:p>
+            <a:r>
+              <a:rPr sz="1200"/>
+              <a:t>validation_plot</a:t>
+            </a:r>
+          </a:p>
+        </p:txBody>
+      </p:sp>
+      <p:sp>
+        <p:nvSpPr>
+          <p:cNvPr id="7" name="PPA::PPA-CASE-B-PHYSICAL::PPC-096AA5FA0BA06EE1::caption_a::caption::CAPTION"/>
+          <p:cNvSpPr txBox="1"/>
+          <p:nvPr/>
+        </p:nvSpPr>
+        <p:spPr>
+          <a:xfrm>
+            <a:off x="1073505" y="3101644"/>
+            <a:ext cx="3033979" cy="466344"/>
+          </a:xfrm>
+          <a:prstGeom prst="rect">
+            <a:avLst/>
+          </a:prstGeom>
+          <a:noFill/>
+        </p:spPr>
+        <p:txBody>
+          <a:bodyPr wrap="none">
+            <a:spAutoFit/>
+          </a:bodyPr>
+          <a:lstStyle/>
+          <a:p>
+            <a:r>
+              <a:rPr sz="1200"/>
+              <a:t>SYNTHETIC_NON_EVIDENCE</a:t>
+            </a:r>
+          </a:p>
+          <a:p>
+            <a:r>
+              <a:rPr sz="1200"/>
+              <a:t>caption</a:t>
+            </a:r>
+          </a:p>
+        </p:txBody>
+      </p:sp>
+      <p:sp>
+        <p:nvSpPr>
+          <p:cNvPr id="8" name="PPA::PPA-CASE-B-PHYSICAL::PPC-096AA5FA0BA06EE1::caption_b::caption::REGION-CAPTION_B"/>
+          <p:cNvSpPr txBox="1"/>
+          <p:nvPr/>
+        </p:nvSpPr>
+        <p:spPr>
+          <a:xfrm>
+            <a:off x="4432554" y="3101644"/>
+            <a:ext cx="3033979" cy="466344"/>
+          </a:xfrm>
+          <a:prstGeom prst="rect">
+            <a:avLst/>
+          </a:prstGeom>
+          <a:noFill/>
+        </p:spPr>
+        <p:txBody>
+          <a:bodyPr wrap="none">
+            <a:spAutoFit/>
+          </a:bodyPr>
+          <a:lstStyle/>
+          <a:p>
+            <a:r>
+              <a:rPr sz="1200"/>
+              <a:t>SYNTHETIC_NON_EVIDENCE</a:t>
+            </a:r>
+          </a:p>
+          <a:p>
+            <a:r>
+              <a:rPr sz="1200"/>
+              <a:t>caption</a:t>
+            </a:r>
+          </a:p>
+        </p:txBody>
+      </p:sp>
+      <p:sp>
+        <p:nvSpPr>
+          <p:cNvPr id="9" name="PPA::PPA-CASE-B-PHYSICAL::PPC-096AA5FA0BA06EE1::measurement_c::secondary_visual::PHOTO-2"/>
+          <p:cNvSpPr txBox="1"/>
+          <p:nvPr/>
+        </p:nvSpPr>
+        <p:spPr>
+          <a:xfrm>
+            <a:off x="7791602" y="3847795"/>
+            <a:ext cx="3250692" cy="932688"/>
+          </a:xfrm>
+          <a:prstGeom prst="rect">
+            <a:avLst/>
+          </a:prstGeom>
+          <a:noFill/>
+        </p:spPr>
+        <p:txBody>
+          <a:bodyPr wrap="none">
+            <a:spAutoFit/>
+          </a:bodyPr>
+          <a:lstStyle/>
+          <a:p>
+            <a:r>
+              <a:rPr sz="1200"/>
+              <a:t>SYNTHETIC_NON_EVIDENCE</a:t>
+            </a:r>
+          </a:p>
+          <a:p>
+            <a:r>
+              <a:rPr sz="1200"/>
+              <a:t>secondary_visual</a:t>
+            </a:r>
+          </a:p>
+        </p:txBody>
+      </p:sp>
+      <p:sp>
+        <p:nvSpPr>
+          <p:cNvPr id="10" name="PPA::PPA-CASE-B-PHYSICAL::PPC-096AA5FA0BA06EE1::context::compact_context::REGION-CONTEXT"/>
+          <p:cNvSpPr txBox="1"/>
+          <p:nvPr/>
+        </p:nvSpPr>
+        <p:spPr>
+          <a:xfrm>
+            <a:off x="1073505" y="4034332"/>
+            <a:ext cx="6393027" cy="792784"/>
+          </a:xfrm>
+          <a:prstGeom prst="rect">
+            <a:avLst/>
+          </a:prstGeom>
+          <a:noFill/>
+        </p:spPr>
+        <p:txBody>
+          <a:bodyPr wrap="none">
+            <a:spAutoFit/>
+          </a:bodyPr>
+          <a:lstStyle/>
+          <a:p>
+            <a:r>
+              <a:rPr sz="1200"/>
+              <a:t>SYNTHETIC_NON_EVIDENCE</a:t>
+            </a:r>
+          </a:p>
+          <a:p>
+            <a:r>
+              <a:rPr sz="1200"/>
+              <a:t>compact_context</a:t>
             </a:r>
           </a:p>
         </p:txBody>
@@ -4524,7 +5568,7 @@
       <p:grpSpPr/>
       <p:sp>
         <p:nvSpPr>
-          <p:cNvPr id="2" name="tds-title:PPA-CASE-C-RESULT"/>
+          <p:cNvPr id="2" name="tds-title:PPA-CASE-C-RESULT::PPC-6DC7B591568B4649"/>
           <p:cNvSpPr>
             <a:spLocks noGrp="1"/>
           </p:cNvSpPr>
@@ -4544,7 +5588,7 @@
           <a:p>
             <a:r>
               <a:rPr sz="2200"/>
-              <a:t>Planner review CASE-C-RESULT</a:t>
+              <a:t>Planner review CASE-C-RESULT | BCF-REAL-RESULT-VALIDATION</a:t>
             </a:r>
           </a:p>
         </p:txBody>
@@ -4568,14 +5612,14 @@
       </p:sp>
       <p:sp>
         <p:nvSpPr>
-          <p:cNvPr id="4" name="tds-composition-text:PPA-CASE-C-RESULT"/>
+          <p:cNvPr id="4" name="PPA::PPA-CASE-C-RESULT::PPC-6DC7B591568B4649::result::primary_visual::PLOT"/>
           <p:cNvSpPr txBox="1"/>
           <p:nvPr/>
         </p:nvSpPr>
         <p:spPr>
           <a:xfrm>
-            <a:off x="640080" y="1280160"/>
-            <a:ext cx="3566160" cy="4297680"/>
+            <a:off x="1073505" y="1422806"/>
+            <a:ext cx="6718096" cy="3124504"/>
           </a:xfrm>
           <a:prstGeom prst="rect">
             <a:avLst/>
@@ -4589,22 +5633,84 @@
           <a:lstStyle/>
           <a:p>
             <a:r>
-              <a:rPr sz="1800"/>
-              <a:t>BCF-REAL-RESULT-VALIDATION</a:t>
-            </a:r>
-          </a:p>
-          <a:p/>
-          <a:p>
-            <a:r>
-              <a:rPr sz="1800"/>
-              <a:t>dominant_result_plot / metric_callout / compact_context</a:t>
-            </a:r>
-          </a:p>
-          <a:p/>
-          <a:p>
-            <a:r>
-              <a:rPr sz="1800"/>
-              <a:t>automatic</a:t>
+              <a:rPr sz="1200"/>
+              <a:t>SYNTHETIC_NON_EVIDENCE</a:t>
+            </a:r>
+          </a:p>
+          <a:p>
+            <a:r>
+              <a:rPr sz="1200"/>
+              <a:t>primary_visual</a:t>
+            </a:r>
+          </a:p>
+        </p:txBody>
+      </p:sp>
+      <p:sp>
+        <p:nvSpPr>
+          <p:cNvPr id="5" name="PPA::PPA-CASE-C-RESULT::PPC-6DC7B591568B4649::metric::metric_callout::METRIC"/>
+          <p:cNvSpPr txBox="1"/>
+          <p:nvPr/>
+        </p:nvSpPr>
+        <p:spPr>
+          <a:xfrm>
+            <a:off x="8441740" y="1516075"/>
+            <a:ext cx="2600553" cy="1025956"/>
+          </a:xfrm>
+          <a:prstGeom prst="rect">
+            <a:avLst/>
+          </a:prstGeom>
+          <a:noFill/>
+        </p:spPr>
+        <p:txBody>
+          <a:bodyPr wrap="none">
+            <a:spAutoFit/>
+          </a:bodyPr>
+          <a:lstStyle/>
+          <a:p>
+            <a:r>
+              <a:rPr sz="1200"/>
+              <a:t>SYNTHETIC_NON_EVIDENCE</a:t>
+            </a:r>
+          </a:p>
+          <a:p>
+            <a:r>
+              <a:rPr sz="1200"/>
+              <a:t>metric_callout</a:t>
+            </a:r>
+          </a:p>
+        </p:txBody>
+      </p:sp>
+      <p:sp>
+        <p:nvSpPr>
+          <p:cNvPr id="6" name="PPA::PPA-CASE-C-RESULT::PPC-6DC7B591568B4649::context::compact_context::REGION-CONTEXT"/>
+          <p:cNvSpPr txBox="1"/>
+          <p:nvPr/>
+        </p:nvSpPr>
+        <p:spPr>
+          <a:xfrm>
+            <a:off x="8441740" y="3008376"/>
+            <a:ext cx="2600553" cy="1538935"/>
+          </a:xfrm>
+          <a:prstGeom prst="rect">
+            <a:avLst/>
+          </a:prstGeom>
+          <a:noFill/>
+        </p:spPr>
+        <p:txBody>
+          <a:bodyPr wrap="none">
+            <a:spAutoFit/>
+          </a:bodyPr>
+          <a:lstStyle/>
+          <a:p>
+            <a:r>
+              <a:rPr sz="1200"/>
+              <a:t>SYNTHETIC_NON_EVIDENCE</a:t>
+            </a:r>
+          </a:p>
+          <a:p>
+            <a:r>
+              <a:rPr sz="1200"/>
+              <a:t>compact_context</a:t>
             </a:r>
           </a:p>
         </p:txBody>
@@ -4629,7 +5735,7 @@
       <p:grpSpPr/>
       <p:sp>
         <p:nvSpPr>
-          <p:cNvPr id="2" name="tds-title:PPA-CASE-D-MULTIMODAL"/>
+          <p:cNvPr id="2" name="tds-title:PPA-CASE-D-MULTIMODAL::PPC-B2E8AD28884FEC68"/>
           <p:cNvSpPr>
             <a:spLocks noGrp="1"/>
           </p:cNvSpPr>
@@ -4649,7 +5755,7 @@
           <a:p>
             <a:r>
               <a:rPr sz="2200"/>
-              <a:t>Planner review CASE-D-MULTIMODAL</a:t>
+              <a:t>Planner review CASE-D-MULTIMODAL | BCF-PHYSICAL-VALIDATION-MATRIX</a:t>
             </a:r>
           </a:p>
         </p:txBody>
@@ -4673,14 +5779,14 @@
       </p:sp>
       <p:sp>
         <p:nvSpPr>
-          <p:cNvPr id="4" name="tds-composition-text:PPA-CASE-D-MULTIMODAL"/>
+          <p:cNvPr id="4" name="PPA::PPA-CASE-D-MULTIMODAL::PPC-B2E8AD28884FEC68::photo_a::primary_visual::PHOTO"/>
           <p:cNvSpPr txBox="1"/>
           <p:nvPr/>
         </p:nvSpPr>
         <p:spPr>
           <a:xfrm>
-            <a:off x="640080" y="1280160"/>
-            <a:ext cx="3566160" cy="4297680"/>
+            <a:off x="1073505" y="1376172"/>
+            <a:ext cx="3033979" cy="1538935"/>
           </a:xfrm>
           <a:prstGeom prst="rect">
             <a:avLst/>
@@ -4694,22 +5800,224 @@
           <a:lstStyle/>
           <a:p>
             <a:r>
-              <a:rPr sz="1800"/>
-              <a:t>BCF-PHYSICAL-VALIDATION-MATRIX</a:t>
-            </a:r>
-          </a:p>
-          <a:p/>
-          <a:p>
-            <a:r>
-              <a:rPr sz="1800"/>
-              <a:t>physical_visual_grid / validation_plot / caption_matrix</a:t>
-            </a:r>
-          </a:p>
-          <a:p/>
-          <a:p>
-            <a:r>
-              <a:rPr sz="1800"/>
-              <a:t>automatic</a:t>
+              <a:rPr sz="1200"/>
+              <a:t>SYNTHETIC_NON_EVIDENCE</a:t>
+            </a:r>
+          </a:p>
+          <a:p>
+            <a:r>
+              <a:rPr sz="1200"/>
+              <a:t>primary_visual</a:t>
+            </a:r>
+          </a:p>
+        </p:txBody>
+      </p:sp>
+      <p:sp>
+        <p:nvSpPr>
+          <p:cNvPr id="5" name="PPA::PPA-CASE-D-MULTIMODAL::PPC-B2E8AD28884FEC68::photo_b::secondary_visual::REGION-PHOTO_B"/>
+          <p:cNvSpPr txBox="1"/>
+          <p:nvPr/>
+        </p:nvSpPr>
+        <p:spPr>
+          <a:xfrm>
+            <a:off x="4432554" y="1376172"/>
+            <a:ext cx="3033979" cy="1538935"/>
+          </a:xfrm>
+          <a:prstGeom prst="rect">
+            <a:avLst/>
+          </a:prstGeom>
+          <a:noFill/>
+        </p:spPr>
+        <p:txBody>
+          <a:bodyPr wrap="none">
+            <a:spAutoFit/>
+          </a:bodyPr>
+          <a:lstStyle/>
+          <a:p>
+            <a:r>
+              <a:rPr sz="1200"/>
+              <a:t>SYNTHETIC_NON_EVIDENCE</a:t>
+            </a:r>
+          </a:p>
+          <a:p>
+            <a:r>
+              <a:rPr sz="1200"/>
+              <a:t>secondary_visual</a:t>
+            </a:r>
+          </a:p>
+        </p:txBody>
+      </p:sp>
+      <p:sp>
+        <p:nvSpPr>
+          <p:cNvPr id="6" name="PPA::PPA-CASE-D-MULTIMODAL::PPC-B2E8AD28884FEC68::plot::validation_plot::REGION-PLOT"/>
+          <p:cNvSpPr txBox="1"/>
+          <p:nvPr/>
+        </p:nvSpPr>
+        <p:spPr>
+          <a:xfrm>
+            <a:off x="7791602" y="1376172"/>
+            <a:ext cx="3250692" cy="2238451"/>
+          </a:xfrm>
+          <a:prstGeom prst="rect">
+            <a:avLst/>
+          </a:prstGeom>
+          <a:noFill/>
+        </p:spPr>
+        <p:txBody>
+          <a:bodyPr wrap="none">
+            <a:spAutoFit/>
+          </a:bodyPr>
+          <a:lstStyle/>
+          <a:p>
+            <a:r>
+              <a:rPr sz="1200"/>
+              <a:t>SYNTHETIC_NON_EVIDENCE</a:t>
+            </a:r>
+          </a:p>
+          <a:p>
+            <a:r>
+              <a:rPr sz="1200"/>
+              <a:t>validation_plot</a:t>
+            </a:r>
+          </a:p>
+        </p:txBody>
+      </p:sp>
+      <p:sp>
+        <p:nvSpPr>
+          <p:cNvPr id="7" name="PPA::PPA-CASE-D-MULTIMODAL::PPC-B2E8AD28884FEC68::caption_a::caption::CAPTION"/>
+          <p:cNvSpPr txBox="1"/>
+          <p:nvPr/>
+        </p:nvSpPr>
+        <p:spPr>
+          <a:xfrm>
+            <a:off x="1073505" y="3101644"/>
+            <a:ext cx="3033979" cy="466344"/>
+          </a:xfrm>
+          <a:prstGeom prst="rect">
+            <a:avLst/>
+          </a:prstGeom>
+          <a:noFill/>
+        </p:spPr>
+        <p:txBody>
+          <a:bodyPr wrap="none">
+            <a:spAutoFit/>
+          </a:bodyPr>
+          <a:lstStyle/>
+          <a:p>
+            <a:r>
+              <a:rPr sz="1200"/>
+              <a:t>SYNTHETIC_NON_EVIDENCE</a:t>
+            </a:r>
+          </a:p>
+          <a:p>
+            <a:r>
+              <a:rPr sz="1200"/>
+              <a:t>caption</a:t>
+            </a:r>
+          </a:p>
+        </p:txBody>
+      </p:sp>
+      <p:sp>
+        <p:nvSpPr>
+          <p:cNvPr id="8" name="PPA::PPA-CASE-D-MULTIMODAL::PPC-B2E8AD28884FEC68::caption_b::caption::REGION-CAPTION_B"/>
+          <p:cNvSpPr txBox="1"/>
+          <p:nvPr/>
+        </p:nvSpPr>
+        <p:spPr>
+          <a:xfrm>
+            <a:off x="4432554" y="3101644"/>
+            <a:ext cx="3033979" cy="466344"/>
+          </a:xfrm>
+          <a:prstGeom prst="rect">
+            <a:avLst/>
+          </a:prstGeom>
+          <a:noFill/>
+        </p:spPr>
+        <p:txBody>
+          <a:bodyPr wrap="none">
+            <a:spAutoFit/>
+          </a:bodyPr>
+          <a:lstStyle/>
+          <a:p>
+            <a:r>
+              <a:rPr sz="1200"/>
+              <a:t>SYNTHETIC_NON_EVIDENCE</a:t>
+            </a:r>
+          </a:p>
+          <a:p>
+            <a:r>
+              <a:rPr sz="1200"/>
+              <a:t>caption</a:t>
+            </a:r>
+          </a:p>
+        </p:txBody>
+      </p:sp>
+      <p:sp>
+        <p:nvSpPr>
+          <p:cNvPr id="9" name="PPA::PPA-CASE-D-MULTIMODAL::PPC-B2E8AD28884FEC68::measurement_c::secondary_visual::PLOT"/>
+          <p:cNvSpPr txBox="1"/>
+          <p:nvPr/>
+        </p:nvSpPr>
+        <p:spPr>
+          <a:xfrm>
+            <a:off x="7791602" y="3847795"/>
+            <a:ext cx="3250692" cy="932688"/>
+          </a:xfrm>
+          <a:prstGeom prst="rect">
+            <a:avLst/>
+          </a:prstGeom>
+          <a:noFill/>
+        </p:spPr>
+        <p:txBody>
+          <a:bodyPr wrap="none">
+            <a:spAutoFit/>
+          </a:bodyPr>
+          <a:lstStyle/>
+          <a:p>
+            <a:r>
+              <a:rPr sz="1200"/>
+              <a:t>SYNTHETIC_NON_EVIDENCE</a:t>
+            </a:r>
+          </a:p>
+          <a:p>
+            <a:r>
+              <a:rPr sz="1200"/>
+              <a:t>secondary_visual</a:t>
+            </a:r>
+          </a:p>
+        </p:txBody>
+      </p:sp>
+      <p:sp>
+        <p:nvSpPr>
+          <p:cNvPr id="10" name="PPA::PPA-CASE-D-MULTIMODAL::PPC-B2E8AD28884FEC68::context::compact_context::REGION-CONTEXT"/>
+          <p:cNvSpPr txBox="1"/>
+          <p:nvPr/>
+        </p:nvSpPr>
+        <p:spPr>
+          <a:xfrm>
+            <a:off x="1073505" y="4034332"/>
+            <a:ext cx="6393027" cy="792784"/>
+          </a:xfrm>
+          <a:prstGeom prst="rect">
+            <a:avLst/>
+          </a:prstGeom>
+          <a:noFill/>
+        </p:spPr>
+        <p:txBody>
+          <a:bodyPr wrap="none">
+            <a:spAutoFit/>
+          </a:bodyPr>
+          <a:lstStyle/>
+          <a:p>
+            <a:r>
+              <a:rPr sz="1200"/>
+              <a:t>SYNTHETIC_NON_EVIDENCE</a:t>
+            </a:r>
+          </a:p>
+          <a:p>
+            <a:r>
+              <a:rPr sz="1200"/>
+              <a:t>compact_context</a:t>
             </a:r>
           </a:p>
         </p:txBody>
@@ -4734,7 +6042,7 @@
       <p:grpSpPr/>
       <p:sp>
         <p:nvSpPr>
-          <p:cNvPr id="2" name="tds-title:PPA-CASE-E-LITERATURE"/>
+          <p:cNvPr id="2" name="tds-title:PPA-CASE-E-LITERATURE::PPC-2067AD3AC8E29B97"/>
           <p:cNvSpPr>
             <a:spLocks noGrp="1"/>
           </p:cNvSpPr>
@@ -4754,7 +6062,7 @@
           <a:p>
             <a:r>
               <a:rPr sz="2200"/>
-              <a:t>Planner review CASE-E-LITERATURE</a:t>
+              <a:t>Planner review CASE-E-LITERATURE | BCF-LITERATURE-VISUAL-MATRIX</a:t>
             </a:r>
           </a:p>
         </p:txBody>
@@ -4778,14 +6086,14 @@
       </p:sp>
       <p:sp>
         <p:nvSpPr>
-          <p:cNvPr id="4" name="tds-composition-text:PPA-CASE-E-LITERATURE"/>
+          <p:cNvPr id="4" name="PPA::PPA-CASE-E-LITERATURE::PPC-2067AD3AC8E29B97::visual_a::primary_visual::FIG-1"/>
           <p:cNvSpPr txBox="1"/>
           <p:nvPr/>
         </p:nvSpPr>
         <p:spPr>
           <a:xfrm>
-            <a:off x="640080" y="1280160"/>
-            <a:ext cx="3566160" cy="4297680"/>
+            <a:off x="1073505" y="1376172"/>
+            <a:ext cx="3033979" cy="1632204"/>
           </a:xfrm>
           <a:prstGeom prst="rect">
             <a:avLst/>
@@ -4799,22 +6107,224 @@
           <a:lstStyle/>
           <a:p>
             <a:r>
-              <a:rPr sz="1800"/>
-              <a:t>BCF-LITERATURE-VISUAL-MATRIX</a:t>
-            </a:r>
-          </a:p>
-          <a:p/>
-          <a:p>
-            <a:r>
-              <a:rPr sz="1800"/>
-              <a:t>literature_visual_grid / citation_strip / synthesis_callout</a:t>
-            </a:r>
-          </a:p>
-          <a:p/>
-          <a:p>
-            <a:r>
-              <a:rPr sz="1800"/>
-              <a:t>automatic</a:t>
+              <a:rPr sz="1200"/>
+              <a:t>SYNTHETIC_NON_EVIDENCE</a:t>
+            </a:r>
+          </a:p>
+          <a:p>
+            <a:r>
+              <a:rPr sz="1200"/>
+              <a:t>primary_visual</a:t>
+            </a:r>
+          </a:p>
+        </p:txBody>
+      </p:sp>
+      <p:sp>
+        <p:nvSpPr>
+          <p:cNvPr id="5" name="PPA::PPA-CASE-E-LITERATURE::PPC-2067AD3AC8E29B97::visual_b::secondary_visual::FIG-2"/>
+          <p:cNvSpPr txBox="1"/>
+          <p:nvPr/>
+        </p:nvSpPr>
+        <p:spPr>
+          <a:xfrm>
+            <a:off x="4540910" y="1376172"/>
+            <a:ext cx="3033979" cy="1632204"/>
+          </a:xfrm>
+          <a:prstGeom prst="rect">
+            <a:avLst/>
+          </a:prstGeom>
+          <a:noFill/>
+        </p:spPr>
+        <p:txBody>
+          <a:bodyPr wrap="none">
+            <a:spAutoFit/>
+          </a:bodyPr>
+          <a:lstStyle/>
+          <a:p>
+            <a:r>
+              <a:rPr sz="1200"/>
+              <a:t>SYNTHETIC_NON_EVIDENCE</a:t>
+            </a:r>
+          </a:p>
+          <a:p>
+            <a:r>
+              <a:rPr sz="1200"/>
+              <a:t>secondary_visual</a:t>
+            </a:r>
+          </a:p>
+        </p:txBody>
+      </p:sp>
+      <p:sp>
+        <p:nvSpPr>
+          <p:cNvPr id="6" name="PPA::PPA-CASE-E-LITERATURE::PPC-2067AD3AC8E29B97::visual_c::secondary_visual::REGION-VISUAL_C"/>
+          <p:cNvSpPr txBox="1"/>
+          <p:nvPr/>
+        </p:nvSpPr>
+        <p:spPr>
+          <a:xfrm>
+            <a:off x="8008315" y="1376172"/>
+            <a:ext cx="3033979" cy="1632204"/>
+          </a:xfrm>
+          <a:prstGeom prst="rect">
+            <a:avLst/>
+          </a:prstGeom>
+          <a:noFill/>
+        </p:spPr>
+        <p:txBody>
+          <a:bodyPr wrap="none">
+            <a:spAutoFit/>
+          </a:bodyPr>
+          <a:lstStyle/>
+          <a:p>
+            <a:r>
+              <a:rPr sz="1200"/>
+              <a:t>SYNTHETIC_NON_EVIDENCE</a:t>
+            </a:r>
+          </a:p>
+          <a:p>
+            <a:r>
+              <a:rPr sz="1200"/>
+              <a:t>secondary_visual</a:t>
+            </a:r>
+          </a:p>
+        </p:txBody>
+      </p:sp>
+      <p:sp>
+        <p:nvSpPr>
+          <p:cNvPr id="7" name="PPA::PPA-CASE-E-LITERATURE::PPC-2067AD3AC8E29B97::cite_a::citation_strip::CITE"/>
+          <p:cNvSpPr txBox="1"/>
+          <p:nvPr/>
+        </p:nvSpPr>
+        <p:spPr>
+          <a:xfrm>
+            <a:off x="1073505" y="3194913"/>
+            <a:ext cx="3033979" cy="373075"/>
+          </a:xfrm>
+          <a:prstGeom prst="rect">
+            <a:avLst/>
+          </a:prstGeom>
+          <a:noFill/>
+        </p:spPr>
+        <p:txBody>
+          <a:bodyPr wrap="none">
+            <a:spAutoFit/>
+          </a:bodyPr>
+          <a:lstStyle/>
+          <a:p>
+            <a:r>
+              <a:rPr sz="1200"/>
+              <a:t>SYNTHETIC_NON_EVIDENCE</a:t>
+            </a:r>
+          </a:p>
+          <a:p>
+            <a:r>
+              <a:rPr sz="1200"/>
+              <a:t>citation_strip</a:t>
+            </a:r>
+          </a:p>
+        </p:txBody>
+      </p:sp>
+      <p:sp>
+        <p:nvSpPr>
+          <p:cNvPr id="8" name="PPA::PPA-CASE-E-LITERATURE::PPC-2067AD3AC8E29B97::cite_b::citation_strip::REGION-CITE_B"/>
+          <p:cNvSpPr txBox="1"/>
+          <p:nvPr/>
+        </p:nvSpPr>
+        <p:spPr>
+          <a:xfrm>
+            <a:off x="4540910" y="3194913"/>
+            <a:ext cx="3033979" cy="373075"/>
+          </a:xfrm>
+          <a:prstGeom prst="rect">
+            <a:avLst/>
+          </a:prstGeom>
+          <a:noFill/>
+        </p:spPr>
+        <p:txBody>
+          <a:bodyPr wrap="none">
+            <a:spAutoFit/>
+          </a:bodyPr>
+          <a:lstStyle/>
+          <a:p>
+            <a:r>
+              <a:rPr sz="1200"/>
+              <a:t>SYNTHETIC_NON_EVIDENCE</a:t>
+            </a:r>
+          </a:p>
+          <a:p>
+            <a:r>
+              <a:rPr sz="1200"/>
+              <a:t>citation_strip</a:t>
+            </a:r>
+          </a:p>
+        </p:txBody>
+      </p:sp>
+      <p:sp>
+        <p:nvSpPr>
+          <p:cNvPr id="9" name="PPA::PPA-CASE-E-LITERATURE::PPC-2067AD3AC8E29B97::cite_c::citation_strip::REGION-CITE_C"/>
+          <p:cNvSpPr txBox="1"/>
+          <p:nvPr/>
+        </p:nvSpPr>
+        <p:spPr>
+          <a:xfrm>
+            <a:off x="8008315" y="3194913"/>
+            <a:ext cx="3033979" cy="373075"/>
+          </a:xfrm>
+          <a:prstGeom prst="rect">
+            <a:avLst/>
+          </a:prstGeom>
+          <a:noFill/>
+        </p:spPr>
+        <p:txBody>
+          <a:bodyPr wrap="none">
+            <a:spAutoFit/>
+          </a:bodyPr>
+          <a:lstStyle/>
+          <a:p>
+            <a:r>
+              <a:rPr sz="1200"/>
+              <a:t>SYNTHETIC_NON_EVIDENCE</a:t>
+            </a:r>
+          </a:p>
+          <a:p>
+            <a:r>
+              <a:rPr sz="1200"/>
+              <a:t>citation_strip</a:t>
+            </a:r>
+          </a:p>
+        </p:txBody>
+      </p:sp>
+      <p:sp>
+        <p:nvSpPr>
+          <p:cNvPr id="10" name="PPA::PPA-CASE-E-LITERATURE::PPC-2067AD3AC8E29B97::synthesis::synthesis_callout::REGION-SYNTHESIS"/>
+          <p:cNvSpPr txBox="1"/>
+          <p:nvPr/>
+        </p:nvSpPr>
+        <p:spPr>
+          <a:xfrm>
+            <a:off x="1073505" y="4034332"/>
+            <a:ext cx="9968788" cy="746150"/>
+          </a:xfrm>
+          <a:prstGeom prst="rect">
+            <a:avLst/>
+          </a:prstGeom>
+          <a:noFill/>
+        </p:spPr>
+        <p:txBody>
+          <a:bodyPr wrap="none">
+            <a:spAutoFit/>
+          </a:bodyPr>
+          <a:lstStyle/>
+          <a:p>
+            <a:r>
+              <a:rPr sz="1200"/>
+              <a:t>SYNTHETIC_NON_EVIDENCE</a:t>
+            </a:r>
+          </a:p>
+          <a:p>
+            <a:r>
+              <a:rPr sz="1200"/>
+              <a:t>synthesis_callout</a:t>
             </a:r>
           </a:p>
         </p:txBody>
@@ -4839,7 +6349,7 @@
       <p:grpSpPr/>
       <p:sp>
         <p:nvSpPr>
-          <p:cNvPr id="2" name="tds-title:PPA-CASE-F-COMPARISON"/>
+          <p:cNvPr id="2" name="tds-title:PPA-CASE-F-COMPARISON::PPC-1BB2BEBF7E6618D7"/>
           <p:cNvSpPr>
             <a:spLocks noGrp="1"/>
           </p:cNvSpPr>
@@ -4859,7 +6369,7 @@
           <a:p>
             <a:r>
               <a:rPr sz="2200"/>
-              <a:t>Planner review CASE-F-COMPARISON</a:t>
+              <a:t>Planner review CASE-F-COMPARISON | BCF-TECHNOLOGY-COMPARISON</a:t>
             </a:r>
           </a:p>
         </p:txBody>
@@ -4883,14 +6393,14 @@
       </p:sp>
       <p:sp>
         <p:nvSpPr>
-          <p:cNvPr id="4" name="tds-composition-text:PPA-CASE-F-COMPARISON"/>
+          <p:cNvPr id="4" name="PPA::PPA-CASE-F-COMPARISON::PPC-1BB2BEBF7E6618D7::approach_a::primary_visual::A"/>
           <p:cNvSpPr txBox="1"/>
           <p:nvPr/>
         </p:nvSpPr>
         <p:spPr>
           <a:xfrm>
-            <a:off x="640080" y="1280160"/>
-            <a:ext cx="3566160" cy="4297680"/>
+            <a:off x="1073505" y="1422806"/>
+            <a:ext cx="3033979" cy="2238451"/>
           </a:xfrm>
           <a:prstGeom prst="rect">
             <a:avLst/>
@@ -4904,22 +6414,119 @@
           <a:lstStyle/>
           <a:p>
             <a:r>
-              <a:rPr sz="1800"/>
-              <a:t>BCF-TECHNOLOGY-COMPARISON</a:t>
-            </a:r>
-          </a:p>
-          <a:p/>
-          <a:p>
-            <a:r>
-              <a:rPr sz="1800"/>
-              <a:t>approach_comparison / criteria_table / mechanism_pair</a:t>
-            </a:r>
-          </a:p>
-          <a:p/>
-          <a:p>
-            <a:r>
-              <a:rPr sz="1800"/>
-              <a:t>automatic</a:t>
+              <a:rPr sz="1200"/>
+              <a:t>SYNTHETIC_NON_EVIDENCE</a:t>
+            </a:r>
+          </a:p>
+          <a:p>
+            <a:r>
+              <a:rPr sz="1200"/>
+              <a:t>primary_visual</a:t>
+            </a:r>
+          </a:p>
+        </p:txBody>
+      </p:sp>
+      <p:sp>
+        <p:nvSpPr>
+          <p:cNvPr id="5" name="PPA::PPA-CASE-F-COMPARISON::PPC-1BB2BEBF7E6618D7::criteria::criteria_table::TABLE"/>
+          <p:cNvSpPr txBox="1"/>
+          <p:nvPr/>
+        </p:nvSpPr>
+        <p:spPr>
+          <a:xfrm>
+            <a:off x="4540910" y="1422806"/>
+            <a:ext cx="3033979" cy="2238451"/>
+          </a:xfrm>
+          <a:prstGeom prst="rect">
+            <a:avLst/>
+          </a:prstGeom>
+          <a:noFill/>
+        </p:spPr>
+        <p:txBody>
+          <a:bodyPr wrap="none">
+            <a:spAutoFit/>
+          </a:bodyPr>
+          <a:lstStyle/>
+          <a:p>
+            <a:r>
+              <a:rPr sz="1200"/>
+              <a:t>SYNTHETIC_NON_EVIDENCE</a:t>
+            </a:r>
+          </a:p>
+          <a:p>
+            <a:r>
+              <a:rPr sz="1200"/>
+              <a:t>criteria_table</a:t>
+            </a:r>
+          </a:p>
+        </p:txBody>
+      </p:sp>
+      <p:sp>
+        <p:nvSpPr>
+          <p:cNvPr id="6" name="PPA::PPA-CASE-F-COMPARISON::PPC-1BB2BEBF7E6618D7::approach_b::secondary_visual::B"/>
+          <p:cNvSpPr txBox="1"/>
+          <p:nvPr/>
+        </p:nvSpPr>
+        <p:spPr>
+          <a:xfrm>
+            <a:off x="8008315" y="1422806"/>
+            <a:ext cx="3033979" cy="2238451"/>
+          </a:xfrm>
+          <a:prstGeom prst="rect">
+            <a:avLst/>
+          </a:prstGeom>
+          <a:noFill/>
+        </p:spPr>
+        <p:txBody>
+          <a:bodyPr wrap="none">
+            <a:spAutoFit/>
+          </a:bodyPr>
+          <a:lstStyle/>
+          <a:p>
+            <a:r>
+              <a:rPr sz="1200"/>
+              <a:t>SYNTHETIC_NON_EVIDENCE</a:t>
+            </a:r>
+          </a:p>
+          <a:p>
+            <a:r>
+              <a:rPr sz="1200"/>
+              <a:t>secondary_visual</a:t>
+            </a:r>
+          </a:p>
+        </p:txBody>
+      </p:sp>
+      <p:sp>
+        <p:nvSpPr>
+          <p:cNvPr id="7" name="PPA::PPA-CASE-F-COMPARISON::PPC-1BB2BEBF7E6618D7::mechanism::mechanism_pair::REGION-MECHANISM"/>
+          <p:cNvSpPr txBox="1"/>
+          <p:nvPr/>
+        </p:nvSpPr>
+        <p:spPr>
+          <a:xfrm>
+            <a:off x="1073505" y="4034332"/>
+            <a:ext cx="9968788" cy="839419"/>
+          </a:xfrm>
+          <a:prstGeom prst="rect">
+            <a:avLst/>
+          </a:prstGeom>
+          <a:noFill/>
+        </p:spPr>
+        <p:txBody>
+          <a:bodyPr wrap="none">
+            <a:spAutoFit/>
+          </a:bodyPr>
+          <a:lstStyle/>
+          <a:p>
+            <a:r>
+              <a:rPr sz="1200"/>
+              <a:t>SYNTHETIC_NON_EVIDENCE</a:t>
+            </a:r>
+          </a:p>
+          <a:p>
+            <a:r>
+              <a:rPr sz="1200"/>
+              <a:t>mechanism_pair</a:t>
             </a:r>
           </a:p>
         </p:txBody>
@@ -4944,7 +6551,7 @@
       <p:grpSpPr/>
       <p:sp>
         <p:nvSpPr>
-          <p:cNvPr id="2" name="tds-title:PPA-CASE-G-PRINCIPLE"/>
+          <p:cNvPr id="2" name="tds-title:PPA-CASE-G-PRINCIPLE::PPC-E866D0D74E77404B"/>
           <p:cNvSpPr>
             <a:spLocks noGrp="1"/>
           </p:cNvSpPr>
@@ -4964,7 +6571,7 @@
           <a:p>
             <a:r>
               <a:rPr sz="2200"/>
-              <a:t>Planner review CASE-G-PRINCIPLE</a:t>
+              <a:t>Planner review CASE-G-PRINCIPLE | BCF-PRINCIPLE-EQUIPMENT-SPLIT</a:t>
             </a:r>
           </a:p>
         </p:txBody>
@@ -4988,14 +6595,14 @@
       </p:sp>
       <p:sp>
         <p:nvSpPr>
-          <p:cNvPr id="4" name="tds-composition-text:PPA-CASE-G-PRINCIPLE"/>
+          <p:cNvPr id="4" name="PPA::PPA-CASE-G-PRINCIPLE::PPC-E866D0D74E77404B::principle::primary_visual::PRINCIPLE"/>
           <p:cNvSpPr txBox="1"/>
           <p:nvPr/>
         </p:nvSpPr>
         <p:spPr>
           <a:xfrm>
-            <a:off x="640080" y="1280160"/>
-            <a:ext cx="3566160" cy="4297680"/>
+            <a:off x="1073505" y="1422806"/>
+            <a:ext cx="4876038" cy="2471623"/>
           </a:xfrm>
           <a:prstGeom prst="rect">
             <a:avLst/>
@@ -5009,22 +6616,119 @@
           <a:lstStyle/>
           <a:p>
             <a:r>
-              <a:rPr sz="1800"/>
-              <a:t>BCF-PRINCIPLE-EQUIPMENT-SPLIT</a:t>
-            </a:r>
-          </a:p>
-          <a:p/>
-          <a:p>
-            <a:r>
-              <a:rPr sz="1800"/>
-              <a:t>principle_schematic / instrument_visual / specification_table</a:t>
-            </a:r>
-          </a:p>
-          <a:p/>
-          <a:p>
-            <a:r>
-              <a:rPr sz="1800"/>
-              <a:t>automatic</a:t>
+              <a:rPr sz="1200"/>
+              <a:t>SYNTHETIC_NON_EVIDENCE</a:t>
+            </a:r>
+          </a:p>
+          <a:p>
+            <a:r>
+              <a:rPr sz="1200"/>
+              <a:t>primary_visual</a:t>
+            </a:r>
+          </a:p>
+        </p:txBody>
+      </p:sp>
+      <p:sp>
+        <p:nvSpPr>
+          <p:cNvPr id="5" name="PPA::PPA-CASE-G-PRINCIPLE::PPC-E866D0D74E77404B::formula::formula::FORMULA"/>
+          <p:cNvSpPr txBox="1"/>
+          <p:nvPr/>
+        </p:nvSpPr>
+        <p:spPr>
+          <a:xfrm>
+            <a:off x="1073505" y="4220870"/>
+            <a:ext cx="4876038" cy="746150"/>
+          </a:xfrm>
+          <a:prstGeom prst="rect">
+            <a:avLst/>
+          </a:prstGeom>
+          <a:noFill/>
+        </p:spPr>
+        <p:txBody>
+          <a:bodyPr wrap="none">
+            <a:spAutoFit/>
+          </a:bodyPr>
+          <a:lstStyle/>
+          <a:p>
+            <a:r>
+              <a:rPr sz="1200"/>
+              <a:t>SYNTHETIC_NON_EVIDENCE</a:t>
+            </a:r>
+          </a:p>
+          <a:p>
+            <a:r>
+              <a:rPr sz="1200"/>
+              <a:t>formula</a:t>
+            </a:r>
+          </a:p>
+        </p:txBody>
+      </p:sp>
+      <p:sp>
+        <p:nvSpPr>
+          <p:cNvPr id="6" name="PPA::PPA-CASE-G-PRINCIPLE::PPC-E866D0D74E77404B::equipment::secondary_visual::EQUIPMENT"/>
+          <p:cNvSpPr txBox="1"/>
+          <p:nvPr/>
+        </p:nvSpPr>
+        <p:spPr>
+          <a:xfrm>
+            <a:off x="6382969" y="1422806"/>
+            <a:ext cx="4659325" cy="2238451"/>
+          </a:xfrm>
+          <a:prstGeom prst="rect">
+            <a:avLst/>
+          </a:prstGeom>
+          <a:noFill/>
+        </p:spPr>
+        <p:txBody>
+          <a:bodyPr wrap="none">
+            <a:spAutoFit/>
+          </a:bodyPr>
+          <a:lstStyle/>
+          <a:p>
+            <a:r>
+              <a:rPr sz="1200"/>
+              <a:t>SYNTHETIC_NON_EVIDENCE</a:t>
+            </a:r>
+          </a:p>
+          <a:p>
+            <a:r>
+              <a:rPr sz="1200"/>
+              <a:t>secondary_visual</a:t>
+            </a:r>
+          </a:p>
+        </p:txBody>
+      </p:sp>
+      <p:sp>
+        <p:nvSpPr>
+          <p:cNvPr id="7" name="PPA::PPA-CASE-G-PRINCIPLE::PPC-E866D0D74E77404B::specification::specification_table::REGION-SPECIFICATION"/>
+          <p:cNvSpPr txBox="1"/>
+          <p:nvPr/>
+        </p:nvSpPr>
+        <p:spPr>
+          <a:xfrm>
+            <a:off x="6382969" y="3941063"/>
+            <a:ext cx="4659325" cy="1025956"/>
+          </a:xfrm>
+          <a:prstGeom prst="rect">
+            <a:avLst/>
+          </a:prstGeom>
+          <a:noFill/>
+        </p:spPr>
+        <p:txBody>
+          <a:bodyPr wrap="none">
+            <a:spAutoFit/>
+          </a:bodyPr>
+          <a:lstStyle/>
+          <a:p>
+            <a:r>
+              <a:rPr sz="1200"/>
+              <a:t>SYNTHETIC_NON_EVIDENCE</a:t>
+            </a:r>
+          </a:p>
+          <a:p>
+            <a:r>
+              <a:rPr sz="1200"/>
+              <a:t>specification_table</a:t>
             </a:r>
           </a:p>
         </p:txBody>
@@ -5049,7 +6753,7 @@
       <p:grpSpPr/>
       <p:sp>
         <p:nvSpPr>
-          <p:cNvPr id="2" name="tds-title:PPA-CASE-H-HISTORICAL"/>
+          <p:cNvPr id="2" name="tds-title:PPA-CASE-H-HISTORICAL::PPC-468E2014216AC345"/>
           <p:cNvSpPr>
             <a:spLocks noGrp="1"/>
           </p:cNvSpPr>
@@ -5069,7 +6773,7 @@
           <a:p>
             <a:r>
               <a:rPr sz="2200"/>
-              <a:t>Planner review CASE-H-HISTORICAL</a:t>
+              <a:t>Planner review CASE-H-HISTORICAL | BCF-REAL-RESULT-VALIDATION</a:t>
             </a:r>
           </a:p>
         </p:txBody>
@@ -5093,14 +6797,14 @@
       </p:sp>
       <p:sp>
         <p:nvSpPr>
-          <p:cNvPr id="4" name="tds-composition-text:PPA-CASE-H-HISTORICAL"/>
+          <p:cNvPr id="4" name="PPA::PPA-CASE-H-HISTORICAL::PPC-468E2014216AC345::result::primary_visual::PLOT"/>
           <p:cNvSpPr txBox="1"/>
           <p:nvPr/>
         </p:nvSpPr>
         <p:spPr>
           <a:xfrm>
-            <a:off x="640080" y="1280160"/>
-            <a:ext cx="3566160" cy="4297680"/>
+            <a:off x="1073505" y="1422806"/>
+            <a:ext cx="6718096" cy="3124504"/>
           </a:xfrm>
           <a:prstGeom prst="rect">
             <a:avLst/>
@@ -5114,22 +6818,84 @@
           <a:lstStyle/>
           <a:p>
             <a:r>
-              <a:rPr sz="1800"/>
-              <a:t>BCF-REAL-RESULT-VALIDATION</a:t>
-            </a:r>
-          </a:p>
-          <a:p/>
-          <a:p>
-            <a:r>
-              <a:rPr sz="1800"/>
-              <a:t>dominant_result_plot / metric_callout / compact_context</a:t>
-            </a:r>
-          </a:p>
-          <a:p/>
-          <a:p>
-            <a:r>
-              <a:rPr sz="1800"/>
-              <a:t>historical_reuse</a:t>
+              <a:rPr sz="1200"/>
+              <a:t>SYNTHETIC_NON_EVIDENCE</a:t>
+            </a:r>
+          </a:p>
+          <a:p>
+            <a:r>
+              <a:rPr sz="1200"/>
+              <a:t>primary_visual</a:t>
+            </a:r>
+          </a:p>
+        </p:txBody>
+      </p:sp>
+      <p:sp>
+        <p:nvSpPr>
+          <p:cNvPr id="5" name="PPA::PPA-CASE-H-HISTORICAL::PPC-468E2014216AC345::metric::metric_callout::METRIC"/>
+          <p:cNvSpPr txBox="1"/>
+          <p:nvPr/>
+        </p:nvSpPr>
+        <p:spPr>
+          <a:xfrm>
+            <a:off x="8441740" y="1516075"/>
+            <a:ext cx="2600553" cy="1025956"/>
+          </a:xfrm>
+          <a:prstGeom prst="rect">
+            <a:avLst/>
+          </a:prstGeom>
+          <a:noFill/>
+        </p:spPr>
+        <p:txBody>
+          <a:bodyPr wrap="none">
+            <a:spAutoFit/>
+          </a:bodyPr>
+          <a:lstStyle/>
+          <a:p>
+            <a:r>
+              <a:rPr sz="1200"/>
+              <a:t>SYNTHETIC_NON_EVIDENCE</a:t>
+            </a:r>
+          </a:p>
+          <a:p>
+            <a:r>
+              <a:rPr sz="1200"/>
+              <a:t>metric_callout</a:t>
+            </a:r>
+          </a:p>
+        </p:txBody>
+      </p:sp>
+      <p:sp>
+        <p:nvSpPr>
+          <p:cNvPr id="6" name="PPA::PPA-CASE-H-HISTORICAL::PPC-468E2014216AC345::context::compact_context::REGION-CONTEXT"/>
+          <p:cNvSpPr txBox="1"/>
+          <p:nvPr/>
+        </p:nvSpPr>
+        <p:spPr>
+          <a:xfrm>
+            <a:off x="8441740" y="3008376"/>
+            <a:ext cx="2600553" cy="1538935"/>
+          </a:xfrm>
+          <a:prstGeom prst="rect">
+            <a:avLst/>
+          </a:prstGeom>
+          <a:noFill/>
+        </p:spPr>
+        <p:txBody>
+          <a:bodyPr wrap="none">
+            <a:spAutoFit/>
+          </a:bodyPr>
+          <a:lstStyle/>
+          <a:p>
+            <a:r>
+              <a:rPr sz="1200"/>
+              <a:t>SYNTHETIC_NON_EVIDENCE</a:t>
+            </a:r>
+          </a:p>
+          <a:p>
+            <a:r>
+              <a:rPr sz="1200"/>
+              <a:t>compact_context</a:t>
             </a:r>
           </a:p>
         </p:txBody>
@@ -5154,7 +6920,7 @@
       <p:grpSpPr/>
       <p:sp>
         <p:nvSpPr>
-          <p:cNvPr id="2" name="tds-title:PPA-CASE-I-CONTINUATION"/>
+          <p:cNvPr id="2" name="tds-title:PPA-CASE-I-CONTINUATION::PPC-F1CFC7CC4822B5C0"/>
           <p:cNvSpPr>
             <a:spLocks noGrp="1"/>
           </p:cNvSpPr>
@@ -5174,7 +6940,7 @@
           <a:p>
             <a:r>
               <a:rPr sz="2200"/>
-              <a:t>Planner review CASE-I-CONTINUATION</a:t>
+              <a:t>Planner review CASE-I-CONTINUATION | BCF-HARDWARE-DESIGN-PROCEDURE</a:t>
             </a:r>
           </a:p>
         </p:txBody>
@@ -5198,14 +6964,14 @@
       </p:sp>
       <p:sp>
         <p:nvSpPr>
-          <p:cNvPr id="4" name="tds-composition-text:PPA-CASE-I-CONTINUATION"/>
+          <p:cNvPr id="4" name="PPA::PPA-CASE-I-CONTINUATION::PPC-F1CFC7CC4822B5C0::hardware::primary_visual::CAD"/>
           <p:cNvSpPr txBox="1"/>
           <p:nvPr/>
         </p:nvSpPr>
         <p:spPr>
           <a:xfrm>
-            <a:off x="640080" y="1280160"/>
-            <a:ext cx="3566160" cy="4297680"/>
+            <a:off x="1073505" y="1376172"/>
+            <a:ext cx="6067958" cy="3264408"/>
           </a:xfrm>
           <a:prstGeom prst="rect">
             <a:avLst/>
@@ -5219,22 +6985,84 @@
           <a:lstStyle/>
           <a:p>
             <a:r>
-              <a:rPr sz="1800"/>
-              <a:t>BCF-HARDWARE-DESIGN-PROCEDURE</a:t>
-            </a:r>
-          </a:p>
-          <a:p/>
-          <a:p>
-            <a:r>
-              <a:rPr sz="1800"/>
-              <a:t>large_hardware_visual / procedure_controls / go_criterion</a:t>
-            </a:r>
-          </a:p>
-          <a:p/>
-          <a:p>
-            <a:r>
-              <a:rPr sz="1800"/>
-              <a:t>automatic</a:t>
+              <a:rPr sz="1200"/>
+              <a:t>SYNTHETIC_NON_EVIDENCE</a:t>
+            </a:r>
+          </a:p>
+          <a:p>
+            <a:r>
+              <a:rPr sz="1200"/>
+              <a:t>primary_visual</a:t>
+            </a:r>
+          </a:p>
+        </p:txBody>
+      </p:sp>
+      <p:sp>
+        <p:nvSpPr>
+          <p:cNvPr id="5" name="PPA::PPA-CASE-I-CONTINUATION::PPC-F1CFC7CC4822B5C0::procedure::procedure::CONTROLS"/>
+          <p:cNvSpPr txBox="1"/>
+          <p:nvPr/>
+        </p:nvSpPr>
+        <p:spPr>
+          <a:xfrm>
+            <a:off x="7683246" y="1376172"/>
+            <a:ext cx="3359048" cy="2238451"/>
+          </a:xfrm>
+          <a:prstGeom prst="rect">
+            <a:avLst/>
+          </a:prstGeom>
+          <a:noFill/>
+        </p:spPr>
+        <p:txBody>
+          <a:bodyPr wrap="none">
+            <a:spAutoFit/>
+          </a:bodyPr>
+          <a:lstStyle/>
+          <a:p>
+            <a:r>
+              <a:rPr sz="1200"/>
+              <a:t>SYNTHETIC_NON_EVIDENCE</a:t>
+            </a:r>
+          </a:p>
+          <a:p>
+            <a:r>
+              <a:rPr sz="1200"/>
+              <a:t>procedure</a:t>
+            </a:r>
+          </a:p>
+        </p:txBody>
+      </p:sp>
+      <p:sp>
+        <p:nvSpPr>
+          <p:cNvPr id="6" name="PPA::PPA-CASE-I-CONTINUATION::PPC-F1CFC7CC4822B5C0::go::go_criterion::GO"/>
+          <p:cNvSpPr txBox="1"/>
+          <p:nvPr/>
+        </p:nvSpPr>
+        <p:spPr>
+          <a:xfrm>
+            <a:off x="7683246" y="3941063"/>
+            <a:ext cx="3359048" cy="746150"/>
+          </a:xfrm>
+          <a:prstGeom prst="rect">
+            <a:avLst/>
+          </a:prstGeom>
+          <a:noFill/>
+        </p:spPr>
+        <p:txBody>
+          <a:bodyPr wrap="none">
+            <a:spAutoFit/>
+          </a:bodyPr>
+          <a:lstStyle/>
+          <a:p>
+            <a:r>
+              <a:rPr sz="1200"/>
+              <a:t>SYNTHETIC_NON_EVIDENCE</a:t>
+            </a:r>
+          </a:p>
+          <a:p>
+            <a:r>
+              <a:rPr sz="1200"/>
+              <a:t>go_criterion</a:t>
             </a:r>
           </a:p>
         </p:txBody>

</xml_diff>